<commit_message>
docs(report): refine AI engineering presentation workflow
</commit_message>
<xml_diff>
--- a/docs/report/ai-redefines-software-development-presentation/ai-redefines-software-development-v0.2.pptx
+++ b/docs/report/ai-redefines-software-development-presentation/ai-redefines-software-development-v0.2.pptx
@@ -18,9 +18,10 @@
     <p:sldId id="266" r:id="rId12"/>
     <p:sldId id="267" r:id="rId13"/>
     <p:sldId id="268" r:id="rId14"/>
+    <p:sldId id="269" r:id="rId15"/>
   </p:sldIdLst>
   <p:notesMasterIdLst>
-    <p:notesMasterId r:id="rId15"/>
+    <p:notesMasterId r:id="rId16"/>
   </p:notesMasterIdLst>
   <p:sldSz cx="12191695" cy="6858000"/>
   <p:notesSz cx="6858000" cy="12191695"/>
@@ -607,12 +608,12 @@
           <a:p>
             <a:r>
               <a:rPr lang="en-US" dirty="0"/>
-              <a:t>第 10 页：BitFun 的价值：把开发过程组织成工件流
-建议时长：约 1.4 分钟
-页内重点：重做第九页：四个框图错开，扩展 Planning/Evidence/Review/Self-iteration 的工程含义。
-互动提问：一次失败只是修一个 bug，还是沉淀成下一版工程系统？
-讲稿：回到 BitFun，它不是要证明某个模型更强，而是展示一个智能协作系统的雏形。计划不只是聊天里的 TODO，而应该形成项目可管理的 Spec 或任务工件；证据不只是“我看过代码”，而是日志、复现步骤、测试结果、trace 和差异说明；评审不是实现者自审，而是问题发现、仲裁、修复、验证分离，并把中间产物规范化；自迭代也分层：个人级别是把失败经验变成下一次提示和检查清单，项目级别则是把稳定流程沉淀为 Rules、Skill、模板和质量门禁。这样 AI 不是随意写代码，而是在工件流里工作。
-转场：最后，我们把视角切回开发者：人在这样的系统里到底做什么。</a:t>
+              <a:t>第 10 页：下一代工程方法：让 DFX 与 TDD 变成 Agent 协议
+建议时长：约 1.3 分钟
+页内重点：回应 DFX/TDD 新形态：非特定工程的 AI 下解决方案、细化军规、用例形态升级。
+互动提问：如果代码军规仍会被幻觉绕过，下一层护栏是什么？
+讲稿：这里可以做一个前瞻判断：AI 时代的 DFX 不会只是 Design for X 的静态清单，而会变成一组可执行的 Agent 协议。比如性能、可观测性、安全、可维护性，不再只写在规范里，而是以检查项、基准、trace、回归用例、发布预算的形式进入 Agent 工作流。TDD 也会扩展：不只是先写单元测试再写实现，而是先定义失败证据、属性约束、运行观测和评估集，再让 Agent 在这些证据边界里修改。代码军规仍会有幻觉，所以规则要更细，但更关键的是规则要可执行：能被工具检查、能被 trace 回放、能被 review 独立仲裁。
+转场：把这些方法落到 BitFun，就能看到一个 Agent 工程系统的雏形。</a:t>
             </a:r>
             <a:endParaRPr lang="en-US" dirty="0"/>
           </a:p>
@@ -700,12 +701,12 @@
           <a:p>
             <a:r>
               <a:rPr lang="en-US" dirty="0"/>
-              <a:t>第 11 页：开发者角色：在新工程系统中找准位置
-建议时长：约 1.5 分钟
-页内重点：重做第十页：收敛为四步，明确人在各阶段和 AI 在各阶段的角色。
-互动提问：AI 参与每个阶段后，人类开发者最不可替代的技能是什么？
-讲稿：对学生来说，这页很关键：未来不是“人写代码，AI 帮忙补全”，而是人在不同阶段承担不同关键角色。第一步是定义问题，人负责价值判断、非目标和风险边界，AI 可以帮助整理信息和生成备选方案。第二步是组织上下文，人负责架构取舍和事实源选择，AI 负责检索、摘要和草拟计划。第三步是编排执行，人负责设置权限、节奏、验证矩阵和停止条件，AI 负责生成、修改、运行和反馈。第四步是证据放行，人负责最终责任、质量解释和复盘沉淀，AI 提供 trace、diff、测试结果和改进建议。所以编程基础仍重要，但能力结构会从语法实现，升级到问题定义、系统判断、证据审查和协作治理。
-转场：最后用三条未来判断收束：未来几年软件工程会往哪里走。</a:t>
+              <a:t>第 11 页：BitFun 的价值：把开发过程组织成团队工作流
+建议时长：约 1.4 分钟
+页内重点：把第九页落到可执行方法：Spec/Issue -&gt; Agent Worktree -&gt; Evidence Packet -&gt; Independent Review -&gt; Gate/Merge。
+互动提问：如果多个 Agent 同时参与，团队靠什么判断一个变更可以继续前进？
+讲稿：回到 BitFun，它不是要证明某个模型更强，而是展示一个团队工作流的雏形。更可落地的做法是把一次 AI 开发压成五个稳定环节：第一，任务从 Issue 或 Spec 进入，明确目标、非目标和风险边界；第二，Agent 在隔离工作区执行，避免把探索过程直接污染主分支；第三，执行结束必须生成证据包，包括 diff 摘要、测试结果、日志、trace、未决风险和回滚路径；第四，评审要角色分离，发现问题、仲裁问题、修复问题、验证修复尽量不要由同一个角色闭环；第五，阶段门禁决定能否进入 PR、合并或发布。这里的关键不是记录每一步操作，而是把复杂过程压缩成团队能读、能审、能追责的交付对象和证据。
+转场：最后，我们把视角切回开发者：人在这样的系统里到底做什么。</a:t>
             </a:r>
             <a:endParaRPr lang="en-US" dirty="0"/>
           </a:p>
@@ -793,12 +794,12 @@
           <a:p>
             <a:r>
               <a:rPr lang="en-US" dirty="0"/>
-              <a:t>第 12 页：三个未来判断
-建议时长：约 1.1 分钟
-页内重点：新增前瞻页，补创新性和未来预言。
-互动提问：未来两三年，软件工程里最先被重写的指标和方法是什么？
-讲稿：我用三条判断收束。第一，代码行数会越来越不重要，团队会转向净收益指标：从需求到可验证结果的时间、review 负担、返工率、故障恢复和知识沉淀。第二，架构与规则会更重要，不是因为 AI 不会写代码，而是因为越强的生成能力越需要清晰边界、模块契约、权限模型和可观测性来约束不确定性。第三，TDD、DFX、Code Review 会从人的流程习惯，逐步变成 Agent 可执行的工程协议：测试不只是用例，还是证据接口；评审不只是意见，还是可追踪 Artifact；规范不只是文档，还是工具可以检查的控制面。谁能把这些协议做好，谁就能把 AI 从 demo 推向可靠交付。
-转场：最后进入 Q&amp;A。</a:t>
+              <a:t>第 12 页：开发者角色：在新工程系统中找准位置
+建议时长：约 1.5 分钟
+页内重点：重做第十页：收敛为四步，明确人在各阶段和 AI 在各阶段的角色。
+互动提问：AI 参与每个阶段后，人类开发者最不可替代的技能是什么？
+讲稿：对学生来说，这页很关键：未来不是“人写代码，AI 帮忙补全”，而是人在不同阶段承担不同关键角色。第一步是定义问题，人负责价值判断、非目标和风险边界，AI 可以帮助整理信息和生成备选方案。第二步是组织上下文，人负责架构取舍和事实源选择，AI 负责检索、摘要和草拟计划。第三步是编排执行，人负责设置权限、节奏、验证矩阵和停止条件，AI 负责生成、修改、运行和反馈。第四步是证据放行，人负责最终责任、质量解释和复盘沉淀，AI 提供 trace、diff、测试结果和改进建议。所以编程基础仍重要，但能力结构会从语法实现，升级到问题定义、系统判断、证据审查和协作治理。
+转场：最后用三条未来判断收束：未来几年软件工程会往哪里走。</a:t>
             </a:r>
             <a:endParaRPr lang="en-US" dirty="0"/>
           </a:p>
@@ -886,7 +887,100 @@
           <a:p>
             <a:r>
               <a:rPr lang="en-US" dirty="0"/>
-              <a:t>第 13 页：谢谢
+              <a:t>第 13 页：三个未来判断
+建议时长：约 0.9 分钟
+页内重点：压缩前瞻页，作为收束而不是新增概念。
+互动提问：未来两三年，软件工程里最先被重写的指标和方法是什么？
+讲稿：最后用三条判断收束，不再展开新概念。第一，指标会从代码行数、commit 数转向净收益：需求到证据的时间、评审负担、返工率、故障恢复和知识沉淀。第二，角色会从单一开发者扩展成任务 owner、Agent 编排者、证据审查者和系统治理者，人的价值更多在目标、边界、取舍和责任。第三，工程协议会越来越重要：TDD、DFX、Code Review 不只是人的流程习惯，而会变成 Agent 可读取、可执行、可产证据的协议。未来优秀的软件人才，不只是会用 AI 写代码，而是能把 AI 放进可靠工程系统里工作。
+转场：最后进入 Q&amp;A。</a:t>
+            </a:r>
+            <a:endParaRPr lang="en-US" dirty="0"/>
+          </a:p>
+        </p:txBody>
+      </p:sp>
+      <p:sp>
+        <p:nvSpPr>
+          <p:cNvPr id="4" name="Slide Number Placeholder 3"/>
+          <p:cNvSpPr>
+            <a:spLocks noGrp="1"/>
+          </p:cNvSpPr>
+          <p:nvPr>
+            <p:ph type="sldNum" sz="quarter" idx="10"/>
+          </p:nvPr>
+        </p:nvSpPr>
+        <p:spPr/>
+        <p:txBody>
+          <a:bodyPr/>
+          <a:lstStyle/>
+          <a:p>
+            <a:fld id="{F7021451-1387-4CA6-816F-3879F97B5CBC}" type="slidenum">
+              <a:rPr lang="en-US"/>
+              <a:t>13</a:t>
+            </a:fld>
+            <a:endParaRPr lang="en-US"/>
+          </a:p>
+        </p:txBody>
+      </p:sp>
+    </p:spTree>
+    <p:extLst>
+      <p:ext uri="{BB962C8B-B14F-4D97-AF65-F5344CB8AC3E}">
+        <p14:creationId xmlns:p14="http://schemas.microsoft.com/office/powerpoint/2010/main" val="1024086991"/>
+      </p:ext>
+    </p:extLst>
+  </p:cSld>
+  <p:clrMapOvr>
+    <a:masterClrMapping/>
+  </p:clrMapOvr>
+</p:notes>
+</file>
+
+<file path=ppt/notesSlides/notesSlide14.xml><?xml version="1.0" encoding="utf-8"?>
+<p:notes xmlns:a="http://schemas.openxmlformats.org/drawingml/2006/main" xmlns:r="http://schemas.openxmlformats.org/officeDocument/2006/relationships" xmlns:p="http://schemas.openxmlformats.org/presentationml/2006/main">
+  <p:cSld>
+    <p:spTree>
+      <p:nvGrpSpPr>
+        <p:cNvPr id="1" name=""/>
+        <p:cNvGrpSpPr/>
+        <p:nvPr/>
+      </p:nvGrpSpPr>
+      <p:grpSpPr>
+        <a:xfrm>
+          <a:off x="0" y="0"/>
+          <a:ext cx="0" cy="0"/>
+          <a:chOff x="0" y="0"/>
+          <a:chExt cx="0" cy="0"/>
+        </a:xfrm>
+      </p:grpSpPr>
+      <p:sp>
+        <p:nvSpPr>
+          <p:cNvPr id="2" name="Slide Image Placeholder 1"/>
+          <p:cNvSpPr>
+            <a:spLocks noGrp="1" noRot="1" noChangeAspect="1"/>
+          </p:cNvSpPr>
+          <p:nvPr>
+            <p:ph type="sldImg"/>
+          </p:nvPr>
+        </p:nvSpPr>
+        <p:spPr/>
+      </p:sp>
+      <p:sp>
+        <p:nvSpPr>
+          <p:cNvPr id="3" name="Notes Placeholder 2"/>
+          <p:cNvSpPr>
+            <a:spLocks noGrp="1"/>
+          </p:cNvSpPr>
+          <p:nvPr>
+            <p:ph type="body" idx="1"/>
+          </p:nvPr>
+        </p:nvSpPr>
+        <p:spPr/>
+        <p:txBody>
+          <a:bodyPr/>
+          <a:lstStyle/>
+          <a:p>
+            <a:r>
+              <a:rPr lang="en-US" dirty="0"/>
+              <a:t>第 14 页：谢谢
 建议时长：Q&amp;A
 页内重点：致谢页：去掉上方答疑互动说明，只保留主题和互动问题。
 互动提问：围绕 AI 编程、工程治理和开发者角色继续讨论。
@@ -914,7 +1008,7 @@
           <a:p>
             <a:fld id="{F7021451-1387-4CA6-816F-3879F97B5CBC}" type="slidenum">
               <a:rPr lang="en-US"/>
-              <a:t>13</a:t>
+              <a:t>14</a:t>
             </a:fld>
             <a:endParaRPr lang="en-US"/>
           </a:p>
@@ -1165,11 +1259,11 @@
           <a:p>
             <a:r>
               <a:rPr lang="en-US" dirty="0"/>
-              <a:t>第 4 页：可验证、可治理、可协作
+              <a:t>第 4 页：从人 + 人，到人 + 人 + Agent + Agent
 建议时长：约 1.5 分钟
-页内重点：把第三页改为推导结论：目标方向直接写可验证、可治理、可协作。
-互动提问：可验证、可治理、可协作分别要靠什么工程机制实现？
-讲稿：从 BitFun 这个案例往上抽象，AI 重新定义软件开发，不是因为模型能写多少函数，而是工程对象变大了。过去我们主要管理代码、分支、测试和发布；现在还要管理上下文如何装载、工具权限如何收口、模型输出如何被证据接住、人与 AI 的职责如何切开、中间产物如何被审计。可验证意味着 Finish 不能只是模型说完成，而要绑定测试、日志、trace、复现步骤和用户确认。可治理意味着权限、风险、回滚、合规要在执行链路里硬约束。可协作意味着协作对象从人与人，扩展到人与人加 AI：AI 生成计划、实现、证据和评审建议，人负责目标、取舍、责任和最终放行。
+页内重点：用协作拓扑替换抽象结论：同步 pair、异步委派、角色化 Agent、人工放行。
+互动提问：当 Agent 也能开分支、跑测试、提交 PR 时，团队协作到底变了什么？
+讲稿：从 BitFun 这个案例往上抽象，AI 重新定义软件开发，不只是因为模型能写函数，而是团队协作拓扑变了。第一阶段是人加 AI 的同步 pair coding，AI 在 IDE 里帮你补全、解释和修改。第二阶段是异步委派，比如 GitHub Copilot cloud agent 或 Codex cloud：你把 issue 或任务交给 Agent，它在独立环境里研究、建分支、跑测试、准备 PR。第三阶段是角色化 Agent：实现、测试、评审、安全、文档不一定由同一个 Agent 完成，而是通过 subagents、hooks、trace 和工作流编排形成分工。第四阶段仍然是人类放行：人不需要监督每一步 prompt，而是看目标是否达成、证据包是否足够、风险是否可接受、是否可以合并或发布。所以协作对象从人和人，扩展成了人、Agent、工具和证据共同工作的系统。
 转场：接下来讨论速度：为什么 AI 让探索更快，但不保证交付自然变稳。</a:t>
             </a:r>
             <a:endParaRPr lang="en-US" dirty="0"/>
@@ -1263,7 +1357,7 @@
 页内重点：加入概率性问题、高置信度、开发者信任与产品可信的关系。
 互动提问：同样的模型，为什么有的 Agent 可信，有的 Agent 不可信？
 讲稿：AI 介入之后，研发节奏会从排期驱动部分转向想法驱动：先快速探索，再用证据决定是否继续。但这里的核心不是“模型每次都确定正确”，恰恰相反，模型生成天然带有概率性。新的软件工程范式更像是：允许执行过程多路径探索，但最终放行必须依赖可复现证据。开发者信任来自 Agent 层的保护，比如只读计划、沙箱执行、危险操作拦截、失败回注上下文、trace 可回放；产品可信来自测试、评估集、灰度、监控和人工审批。换句话说，我们不是消灭概率性，而是把概率性关进可观察、可比较、可回滚的工程边界里。
-转场：但是外部数据也提醒我们：速度收益并不是天然指数级增长。</a:t>
+转场：更尖锐的问题是：如果模型本身、团队使用的模型和多 Agent 链路都在波动，工程系统怎么收敛？</a:t>
             </a:r>
             <a:endParaRPr lang="en-US" dirty="0"/>
           </a:p>
@@ -1351,12 +1445,12 @@
           <a:p>
             <a:r>
               <a:rPr lang="en-US" dirty="0"/>
-              <a:t>第 6 页：速度收益不是指数曲线
-建议时长：约 1.4 分钟
-页内重点：补外部信息：DORA、METR、Harness 作为市场和研究佐证。
-互动提问：为什么开发者感觉更快，团队整体却未必同等加速？
-讲稿：外部研究给了我们一个更冷静的视角。DORA 2025 把 AI 描述为组织系统的放大器：高质量组织会被放大，原本碎片化的流程也会被放大；同时它也提醒，采用 AI 不等于自动获得收益，组织需要同步演进文化、流程和系统。METR 在 2025 对成熟开源项目做随机对照实验，发现经验开发者使用当时的 AI 工具反而慢 19%；2026 年 METR 又提醒，AI 工具正在进化，任务选择和多 Agent 使用让测量本身也变难。Harness 2026 则把问题落到工程管理上：很多团队的生产力指标变好，但 code review、修 bug、工具切换等隐形工作也在上升。结论不是 AI 没用，而是不要只用代码量衡量收益。
-转场：所以第一个真正被重新定义的东西，是质量责任。</a:t>
+              <a:t>第 6 页：用可控系统收敛不可控过程
+建议时长：约 1.2 分钟
+页内重点：补充模型波动、概率串联衰减、Agent Team 错误放大，以及阶段性纠错系统。
+互动提问：如果每一步都有 99% 正确率，十步之后系统还可信吗？
+讲稿：这里可以把问题说得更硬一点：AI 的不确定性不只来自某一次回答。团队里不同人可能使用不同模型，同一个模型不同版本能力会变化，甚至在 temperature 很低时同一评审任务也可能出现不一致。再往上，如果一个 Agent Team 中每一步都把前一步的自然语言结论当事实输入，错误就会像串联系统一样累乘：0.99 的十次方大约只有 0.90；更糟的是，很多错误不是独立随机错误，而是会被后续步骤继承并放大。但治理对象要切清楚：模型、提示词、工具调用这些是后台 telemetry，用于复现、审计和失败排查，不应该变成人类日常评审的主要对象。人类应该判断的是交付对象：需求意图是否明确，代码变更是否完整，测试和运行证据是否足够，风险和回滚是否可接受。阶段门禁就是放在阶段转换处的自动控制点，比如从计划到实现、从实现到评审、从评审到合并。它检查的是交付对象和证据包，而不是每一步操作日志：接口契约、影响范围、构建测试、静态检查、风险标签、owner 和回滚路径。Artifact 也要收窄成可长期管理的关键工程产物，包括需求/任务、设计决策、代码 diff、测试证据、评审结论、发布与回滚记录。系统把复杂执行过程压缩成摘要、差异、来源、不一致提示和风险解释，帮助人做判断；只有在高风险、证据冲突或事故复盘时，才需要下钻到模型和执行轨迹。
+转场：有了这层纠偏系统，再看外部数据，会更容易理解为什么速度收益不是天然指数级增长。</a:t>
             </a:r>
             <a:endParaRPr lang="en-US" dirty="0"/>
           </a:p>
@@ -1444,12 +1538,12 @@
           <a:p>
             <a:r>
               <a:rPr lang="en-US" dirty="0"/>
-              <a:t>第 7 页：速度放大之后，质量责任被重新定义
+              <a:t>第 7 页：速度收益不是指数曲线
 建议时长：约 1.2 分钟
-页内重点：优化第六页：放大中部内容，解释从能跑到可放行的距离。
-互动提问：AI 生成的代码能跑之后，距离可合并、可发布、可长期维护还差什么？
-讲稿：当速度被放大之后，质量责任会从“这个功能能不能跑”扩展到“谁确认它可以进入系统”。功能能跑，只说明 happy path 暂时成立；设计不沉淀，意味着需求变化没有变成可复用的决策记录；协作被压缩，意味着个人加 Agent 很快，但团队共识可能不足；修复凭自信，意味着 Agent 可以给出看似合理的 patch，却没有复现、日志和验证。这里的关键是把“高置信度”从模型自信改成工程证据：证据不是附属材料，而是进入合并、发布和复盘的主路径。
-转场：质量责任落地以后，工程治理需要从门禁转向更细的智能护栏。</a:t>
+页内重点：补外部信息：DORA、METR、Harness 作为市场和研究佐证。
+互动提问：为什么开发者感觉更快，团队整体却未必同等加速？
+讲稿：外部研究给了我们一个更冷静的视角。DORA 2025 把 AI 描述为组织系统的放大器：高质量组织会被放大，原本碎片化的流程也会被放大；同时它也提醒，采用 AI 不等于自动获得收益，组织需要同步演进文化、流程和系统。METR 在 2025 对成熟开源项目做随机对照实验，发现经验开发者使用当时的 AI 工具反而慢 19%；2026 年 METR 又提醒，AI 工具正在进化，任务选择和多 Agent 使用让测量本身也变难。Harness 2026 则把问题落到工程管理上：很多团队的生产力指标变好，但 code review、修 bug、工具切换等隐形工作也在上升。结论不是 AI 没用，而是不要只用代码量衡量收益。
+转场：所以第一个真正被重新定义的东西，是质量责任。</a:t>
             </a:r>
             <a:endParaRPr lang="en-US" dirty="0"/>
           </a:p>
@@ -1537,12 +1631,12 @@
           <a:p>
             <a:r>
               <a:rPr lang="en-US" dirty="0"/>
-              <a:t>第 8 页：工程质量：从门禁到智能护栏
-建议时长：约 1.5 分钟
-页内重点：合并原第七/第八页的重复信息，突出责任链、证据链与小批量反制不稳定。
-互动提问：AI 让提交变多以后，维护者和大厂平台到底该看什么？
-讲稿：原先第七页和第八页容易讲成重复的质量术语，这里把它收敛为一个治理问题：开源高质量协作强调公共责任，维护者要提升对陌生贡献或 AI-assisted 变更质量的信任度；大厂复杂交付强调系统连续性，组织要处理 owner、依赖链、合规、发布窗口、线上事故成本，以及贯穿整个系统的确定性工件。两者都不能只靠“多跑测试”。更有效的做法是把变化拆小，把责任、证据和 Artifact 绑定到每个小批次：谁拥有模块，谁确认设计边界，哪些测试和运行指标证明可以前进，失败时如何回滚。
-转场：再往前看，DFX、TDD、架构守护都会出现 AI 时代的新形态。</a:t>
+              <a:t>第 8 页：速度放大之后，质量责任被重新定义
+建议时长：约 1.0 分钟
+页内重点：优化第六页：放大中部内容，解释从能跑到可放行的距离。
+互动提问：AI 生成的代码能跑之后，距离可合并、可发布、可长期维护还差什么？
+讲稿：当速度被放大之后，质量责任会从“这个功能能不能跑”扩展到“谁确认它可以进入系统”。功能能跑，只说明 happy path 暂时成立；设计不沉淀，意味着需求变化没有变成可复用的决策记录；协作被压缩，意味着个人加 Agent 很快，但团队共识可能不足；修复凭自信，意味着 Agent 可以给出看似合理的 patch，却没有复现、日志和验证。这里的关键是把“高置信度”从模型自信改成工程证据：证据不是附属材料，而是进入合并、发布和复盘的主路径。
+转场：质量责任落地以后，工程治理需要从门禁转向更细的智能护栏。</a:t>
             </a:r>
             <a:endParaRPr lang="en-US" dirty="0"/>
           </a:p>
@@ -1630,12 +1724,12 @@
           <a:p>
             <a:r>
               <a:rPr lang="en-US" dirty="0"/>
-              <a:t>第 9 页：下一代工程方法：让 DFX 与 TDD 变成 Agent 协议
-建议时长：约 1.3 分钟
-页内重点：回应 DFX/TDD 新形态：非特定工程的 AI 下解决方案、细化军规、用例形态升级。
-互动提问：如果代码军规仍会被幻觉绕过，下一层护栏是什么？
-讲稿：这里可以做一个前瞻判断：AI 时代的 DFX 不会只是 Design for X 的静态清单，而会变成一组可执行的 Agent 协议。比如性能、可观测性、安全、可维护性，不再只写在规范里，而是以检查项、基准、trace、回归用例、发布预算的形式进入 Agent 工作流。TDD 也会扩展：不只是先写单元测试再写实现，而是先定义失败证据、属性约束、运行观测和评估集，再让 Agent 在这些证据边界里修改。代码军规仍会有幻觉，所以规则要更细，但更关键的是规则要可执行：能被工具检查、能被 trace 回放、能被 review 独立仲裁。
-转场：把这些方法落到 BitFun，就能看到一个 Agent 工程系统的雏形。</a:t>
+              <a:t>第 9 页：工程质量：从门禁到智能护栏
+建议时长：约 1.4 分钟
+页内重点：合并原第七/第八页的重复信息，突出责任链、证据链与小批量反制不稳定。
+互动提问：AI 让提交变多以后，维护者和大厂平台到底该看什么？
+讲稿：原先第七页和第八页容易讲成重复的质量术语，这里把它收敛为一个治理问题：开源高质量协作强调公共责任，维护者要提升对陌生贡献或 AI-assisted 变更质量的信任度；大厂复杂交付强调系统连续性，组织要处理 owner、依赖链、合规、发布窗口、线上事故成本，以及贯穿整个系统的确定性工件。两者都不能只靠“多跑测试”。更有效的做法是把变化拆小，把责任、证据和 Artifact 绑定到每个小批次：谁拥有模块，谁确认设计边界，哪些测试和运行指标证明可以前进，失败时如何回滚。
+转场：再往前看，DFX、TDD、架构守护都会出现 AI 时代的新形态。</a:t>
             </a:r>
             <a:endParaRPr lang="en-US" dirty="0"/>
           </a:p>
@@ -2264,6 +2358,62 @@
 </p:sld>
 </file>
 
+<file path=ppt/slides/slide14.xml><?xml version="1.0" encoding="utf-8"?>
+<p:sld xmlns:a="http://schemas.openxmlformats.org/drawingml/2006/main" xmlns:r="http://schemas.openxmlformats.org/officeDocument/2006/relationships" xmlns:p="http://schemas.openxmlformats.org/presentationml/2006/main">
+  <p:cSld name="Slide 14">
+    <p:bg>
+      <p:bgPr>
+        <a:solidFill>
+          <a:srgbClr val="F6F8FB"/>
+        </a:solidFill>
+      </p:bgPr>
+    </p:bg>
+    <p:spTree>
+      <p:nvGrpSpPr>
+        <p:cNvPr id="1" name=""/>
+        <p:cNvGrpSpPr/>
+        <p:nvPr/>
+      </p:nvGrpSpPr>
+      <p:grpSpPr>
+        <a:xfrm>
+          <a:off x="0" y="0"/>
+          <a:ext cx="0" cy="0"/>
+          <a:chOff x="0" y="0"/>
+          <a:chExt cx="0" cy="0"/>
+        </a:xfrm>
+      </p:grpSpPr>
+      <p:pic>
+        <p:nvPicPr>
+          <p:cNvPr id="2" name="Image 0" descr="D:\workspace\worktree_for_vcoder\BitFun\docs\report\ai-redefines-software-development-presentation\slides-png-v0.2\slide-14.png">    </p:cNvPr>
+          <p:cNvPicPr>
+            <a:picLocks noChangeAspect="1"/>
+          </p:cNvPicPr>
+          <p:nvPr/>
+        </p:nvPicPr>
+        <p:blipFill>
+          <a:blip r:embed="rId1"/>
+          <a:stretch>
+            <a:fillRect/>
+          </a:stretch>
+        </p:blipFill>
+        <p:spPr>
+          <a:xfrm>
+            <a:off x="0" y="0"/>
+            <a:ext cx="12191695" cy="6858000"/>
+          </a:xfrm>
+          <a:prstGeom prst="rect">
+            <a:avLst/>
+          </a:prstGeom>
+        </p:spPr>
+      </p:pic>
+    </p:spTree>
+  </p:cSld>
+  <p:clrMapOvr>
+    <a:masterClrMapping/>
+  </p:clrMapOvr>
+</p:sld>
+</file>
+
 <file path=ppt/slides/slide2.xml><?xml version="1.0" encoding="utf-8"?>
 <p:sld xmlns:a="http://schemas.openxmlformats.org/drawingml/2006/main" xmlns:r="http://schemas.openxmlformats.org/officeDocument/2006/relationships" xmlns:p="http://schemas.openxmlformats.org/presentationml/2006/main">
   <p:cSld name="Slide 2">

</xml_diff>

<commit_message>
docs(report): streamline AI engineering deck narrative
</commit_message>
<xml_diff>
--- a/docs/report/ai-redefines-software-development-presentation/ai-redefines-software-development-v0.2.pptx
+++ b/docs/report/ai-redefines-software-development-presentation/ai-redefines-software-development-v0.2.pptx
@@ -18,10 +18,9 @@
     <p:sldId id="266" r:id="rId12"/>
     <p:sldId id="267" r:id="rId13"/>
     <p:sldId id="268" r:id="rId14"/>
-    <p:sldId id="269" r:id="rId15"/>
   </p:sldIdLst>
   <p:notesMasterIdLst>
-    <p:notesMasterId r:id="rId16"/>
+    <p:notesMasterId r:id="rId15"/>
   </p:notesMasterIdLst>
   <p:sldSz cx="12191695" cy="6858000"/>
   <p:notesSz cx="6858000" cy="12191695"/>
@@ -608,12 +607,12 @@
           <a:p>
             <a:r>
               <a:rPr lang="en-US" dirty="0"/>
-              <a:t>第 10 页：下一代工程方法：让 DFX 与 TDD 变成 Agent 协议
-建议时长：约 1.3 分钟
-页内重点：回应 DFX/TDD 新形态：非特定工程的 AI 下解决方案、细化军规、用例形态升级。
-互动提问：如果代码军规仍会被幻觉绕过，下一层护栏是什么？
-讲稿：这里可以做一个前瞻判断：AI 时代的 DFX 不会只是 Design for X 的静态清单，而会变成一组可执行的 Agent 协议。比如性能、可观测性、安全、可维护性，不再只写在规范里，而是以检查项、基准、trace、回归用例、发布预算的形式进入 Agent 工作流。TDD 也会扩展：不只是先写单元测试再写实现，而是先定义失败证据、属性约束、运行观测和评估集，再让 Agent 在这些证据边界里修改。代码军规仍会有幻觉，所以规则要更细，但更关键的是规则要可执行：能被工具检查、能被 trace 回放、能被 review 独立仲裁。
-转场：把这些方法落到 BitFun，就能看到一个 Agent 工程系统的雏形。</a:t>
+              <a:t>第 10 页：BitFun 的价值：把开发过程组织成团队工作流
+建议时长：约 1.4 分钟
+页内重点：把第九页落到可执行方法：Spec/Issue -&gt; Agent Worktree -&gt; Evidence Packet -&gt; Independent Review -&gt; Gate/Merge。
+互动提问：如果多个 Agent 同时参与，团队靠什么判断一个变更可以继续前进？
+讲稿：回到 BitFun，它不是要证明某个模型更强，而是展示一个团队工作流的雏形。更可落地的做法是把一次 AI 开发压成五个稳定环节：第一，任务从 Issue 或 Spec 进入，明确目标、非目标和风险边界；第二，Agent 在隔离工作区执行，避免把探索过程直接污染主分支；第三，执行结束必须生成证据包，包括 diff 摘要、测试结果、日志、trace、未决风险和回滚路径；第四，评审要角色分离，发现问题、仲裁问题、修复问题、验证修复尽量不要由同一个角色闭环；第五，阶段门禁决定能否进入 PR、合并或发布。这里的关键不是记录每一步操作，而是把复杂过程压缩成团队能读、能审、能追责的交付对象和证据。
+转场：最后，我们把视角切回开发者：人在这样的系统里到底做什么。</a:t>
             </a:r>
             <a:endParaRPr lang="en-US" dirty="0"/>
           </a:p>
@@ -701,12 +700,12 @@
           <a:p>
             <a:r>
               <a:rPr lang="en-US" dirty="0"/>
-              <a:t>第 11 页：BitFun 的价值：把开发过程组织成团队工作流
-建议时长：约 1.4 分钟
-页内重点：把第九页落到可执行方法：Spec/Issue -&gt; Agent Worktree -&gt; Evidence Packet -&gt; Independent Review -&gt; Gate/Merge。
-互动提问：如果多个 Agent 同时参与，团队靠什么判断一个变更可以继续前进？
-讲稿：回到 BitFun，它不是要证明某个模型更强，而是展示一个团队工作流的雏形。更可落地的做法是把一次 AI 开发压成五个稳定环节：第一，任务从 Issue 或 Spec 进入，明确目标、非目标和风险边界；第二，Agent 在隔离工作区执行，避免把探索过程直接污染主分支；第三，执行结束必须生成证据包，包括 diff 摘要、测试结果、日志、trace、未决风险和回滚路径；第四，评审要角色分离，发现问题、仲裁问题、修复问题、验证修复尽量不要由同一个角色闭环；第五，阶段门禁决定能否进入 PR、合并或发布。这里的关键不是记录每一步操作，而是把复杂过程压缩成团队能读、能审、能追责的交付对象和证据。
-转场：最后，我们把视角切回开发者：人在这样的系统里到底做什么。</a:t>
+              <a:t>第 11 页：开发者角色：在新工程系统中找准位置
+建议时长：约 1.5 分钟
+页内重点：收敛为四步，明确人在各阶段和 AI 在各阶段的角色。
+互动提问：AI 参与每个阶段后，人类开发者最不可替代的技能是什么？
+讲稿：对学生来说，这页很关键：未来不是“人写代码，AI 帮忙补全”，而是人在不同阶段承担不同关键角色。第一步是定义问题，人负责价值判断、非目标和风险边界，AI 可以帮助整理信息和生成备选方案。第二步是组织上下文，人负责架构取舍和事实源选择，AI 负责检索、摘要和草拟计划。第三步是编排执行，人负责设置权限、节奏、验证矩阵和停止条件，AI 负责生成、修改、运行和反馈。第四步是证据放行，人负责最终责任、质量解释和复盘沉淀，AI 提供 trace、diff、测试结果和改进建议。所以编程基础仍重要，但能力结构会从语法实现，升级到问题定义、系统判断、证据审查和协作治理。
+转场：最后用三条未来判断收束：未来几年软件工程会往哪里走。</a:t>
             </a:r>
             <a:endParaRPr lang="en-US" dirty="0"/>
           </a:p>
@@ -794,12 +793,12 @@
           <a:p>
             <a:r>
               <a:rPr lang="en-US" dirty="0"/>
-              <a:t>第 12 页：开发者角色：在新工程系统中找准位置
-建议时长：约 1.5 分钟
-页内重点：重做第十页：收敛为四步，明确人在各阶段和 AI 在各阶段的角色。
-互动提问：AI 参与每个阶段后，人类开发者最不可替代的技能是什么？
-讲稿：对学生来说，这页很关键：未来不是“人写代码，AI 帮忙补全”，而是人在不同阶段承担不同关键角色。第一步是定义问题，人负责价值判断、非目标和风险边界，AI 可以帮助整理信息和生成备选方案。第二步是组织上下文，人负责架构取舍和事实源选择，AI 负责检索、摘要和草拟计划。第三步是编排执行，人负责设置权限、节奏、验证矩阵和停止条件，AI 负责生成、修改、运行和反馈。第四步是证据放行，人负责最终责任、质量解释和复盘沉淀，AI 提供 trace、diff、测试结果和改进建议。所以编程基础仍重要，但能力结构会从语法实现，升级到问题定义、系统判断、证据审查和协作治理。
-转场：最后用三条未来判断收束：未来几年软件工程会往哪里走。</a:t>
+              <a:t>第 12 页：三个未来判断
+建议时长：约 0.9 分钟
+页内重点：压缩前瞻页，作为收束而不是新增概念。
+互动提问：未来两三年，软件工程里最先被重写的指标和方法是什么？
+讲稿：最后用三条判断收束，不再展开新概念。第一，指标会从代码行数、commit 数转向净收益：需求到证据的时间、评审负担、返工率、故障恢复和知识沉淀。第二，角色会从单一开发者扩展成任务 owner、Agent 编排者、证据审查者和系统治理者，人的价值更多在目标、边界、取舍和责任。第三，工程协议会越来越重要：TDD、DFX、Code Review 不只是人的流程习惯，而会变成 Agent 可读取、可执行、可产证据的协议。未来优秀的软件人才，不只是会用 AI 写代码，而是能把 AI 放进可靠工程系统里工作。
+转场：最后进入 Q&amp;A。</a:t>
             </a:r>
             <a:endParaRPr lang="en-US" dirty="0"/>
           </a:p>
@@ -887,100 +886,7 @@
           <a:p>
             <a:r>
               <a:rPr lang="en-US" dirty="0"/>
-              <a:t>第 13 页：三个未来判断
-建议时长：约 0.9 分钟
-页内重点：压缩前瞻页，作为收束而不是新增概念。
-互动提问：未来两三年，软件工程里最先被重写的指标和方法是什么？
-讲稿：最后用三条判断收束，不再展开新概念。第一，指标会从代码行数、commit 数转向净收益：需求到证据的时间、评审负担、返工率、故障恢复和知识沉淀。第二，角色会从单一开发者扩展成任务 owner、Agent 编排者、证据审查者和系统治理者，人的价值更多在目标、边界、取舍和责任。第三，工程协议会越来越重要：TDD、DFX、Code Review 不只是人的流程习惯，而会变成 Agent 可读取、可执行、可产证据的协议。未来优秀的软件人才，不只是会用 AI 写代码，而是能把 AI 放进可靠工程系统里工作。
-转场：最后进入 Q&amp;A。</a:t>
-            </a:r>
-            <a:endParaRPr lang="en-US" dirty="0"/>
-          </a:p>
-        </p:txBody>
-      </p:sp>
-      <p:sp>
-        <p:nvSpPr>
-          <p:cNvPr id="4" name="Slide Number Placeholder 3"/>
-          <p:cNvSpPr>
-            <a:spLocks noGrp="1"/>
-          </p:cNvSpPr>
-          <p:nvPr>
-            <p:ph type="sldNum" sz="quarter" idx="10"/>
-          </p:nvPr>
-        </p:nvSpPr>
-        <p:spPr/>
-        <p:txBody>
-          <a:bodyPr/>
-          <a:lstStyle/>
-          <a:p>
-            <a:fld id="{F7021451-1387-4CA6-816F-3879F97B5CBC}" type="slidenum">
-              <a:rPr lang="en-US"/>
-              <a:t>13</a:t>
-            </a:fld>
-            <a:endParaRPr lang="en-US"/>
-          </a:p>
-        </p:txBody>
-      </p:sp>
-    </p:spTree>
-    <p:extLst>
-      <p:ext uri="{BB962C8B-B14F-4D97-AF65-F5344CB8AC3E}">
-        <p14:creationId xmlns:p14="http://schemas.microsoft.com/office/powerpoint/2010/main" val="1024086991"/>
-      </p:ext>
-    </p:extLst>
-  </p:cSld>
-  <p:clrMapOvr>
-    <a:masterClrMapping/>
-  </p:clrMapOvr>
-</p:notes>
-</file>
-
-<file path=ppt/notesSlides/notesSlide14.xml><?xml version="1.0" encoding="utf-8"?>
-<p:notes xmlns:a="http://schemas.openxmlformats.org/drawingml/2006/main" xmlns:r="http://schemas.openxmlformats.org/officeDocument/2006/relationships" xmlns:p="http://schemas.openxmlformats.org/presentationml/2006/main">
-  <p:cSld>
-    <p:spTree>
-      <p:nvGrpSpPr>
-        <p:cNvPr id="1" name=""/>
-        <p:cNvGrpSpPr/>
-        <p:nvPr/>
-      </p:nvGrpSpPr>
-      <p:grpSpPr>
-        <a:xfrm>
-          <a:off x="0" y="0"/>
-          <a:ext cx="0" cy="0"/>
-          <a:chOff x="0" y="0"/>
-          <a:chExt cx="0" cy="0"/>
-        </a:xfrm>
-      </p:grpSpPr>
-      <p:sp>
-        <p:nvSpPr>
-          <p:cNvPr id="2" name="Slide Image Placeholder 1"/>
-          <p:cNvSpPr>
-            <a:spLocks noGrp="1" noRot="1" noChangeAspect="1"/>
-          </p:cNvSpPr>
-          <p:nvPr>
-            <p:ph type="sldImg"/>
-          </p:nvPr>
-        </p:nvSpPr>
-        <p:spPr/>
-      </p:sp>
-      <p:sp>
-        <p:nvSpPr>
-          <p:cNvPr id="3" name="Notes Placeholder 2"/>
-          <p:cNvSpPr>
-            <a:spLocks noGrp="1"/>
-          </p:cNvSpPr>
-          <p:nvPr>
-            <p:ph type="body" idx="1"/>
-          </p:nvPr>
-        </p:nvSpPr>
-        <p:spPr/>
-        <p:txBody>
-          <a:bodyPr/>
-          <a:lstStyle/>
-          <a:p>
-            <a:r>
-              <a:rPr lang="en-US" dirty="0"/>
-              <a:t>第 14 页：谢谢
+              <a:t>第 13 页：谢谢
 建议时长：Q&amp;A
 页内重点：致谢页：去掉上方答疑互动说明，只保留主题和互动问题。
 互动提问：围绕 AI 编程、工程治理和开发者角色继续讨论。
@@ -1008,7 +914,7 @@
           <a:p>
             <a:fld id="{F7021451-1387-4CA6-816F-3879F97B5CBC}" type="slidenum">
               <a:rPr lang="en-US"/>
-              <a:t>14</a:t>
+              <a:t>13</a:t>
             </a:fld>
             <a:endParaRPr lang="en-US"/>
           </a:p>
@@ -1259,12 +1165,12 @@
           <a:p>
             <a:r>
               <a:rPr lang="en-US" dirty="0"/>
-              <a:t>第 4 页：从人 + 人，到人 + 人 + Agent + Agent
-建议时长：约 1.5 分钟
-页内重点：用协作拓扑替换抽象结论：同步 pair、异步委派、角色化 Agent、人工放行。
-互动提问：当 Agent 也能开分支、跑测试、提交 PR 时，团队协作到底变了什么？
-讲稿：从 BitFun 这个案例往上抽象，AI 重新定义软件开发，不只是因为模型能写函数，而是团队协作拓扑变了。第一阶段是人加 AI 的同步 pair coding，AI 在 IDE 里帮你补全、解释和修改。第二阶段是异步委派，比如 GitHub Copilot cloud agent 或 Codex cloud：你把 issue 或任务交给 Agent，它在独立环境里研究、建分支、跑测试、准备 PR。第三阶段是角色化 Agent：实现、测试、评审、安全、文档不一定由同一个 Agent 完成，而是通过 subagents、hooks、trace 和工作流编排形成分工。第四阶段仍然是人类放行：人不需要监督每一步 prompt，而是看目标是否达成、证据包是否足够、风险是否可接受、是否可以合并或发布。所以协作对象从人和人，扩展成了人、Agent、工具和证据共同工作的系统。
-转场：接下来讨论速度：为什么 AI 让探索更快，但不保证交付自然变稳。</a:t>
+              <a:t>第 4 页：主线：产出放大后，协作对象变了
+建议时长：约 1.4 分钟
+页内重点：承接 BitFun 案例，说明代码产出放大后，协作对象从人和代码扩展到 Agent、证据包和责任链。
+互动提问：当 Agent 也能开分支、跑测试、提交 PR 时，团队真正新增的协作对象是什么？
+讲稿：由 BitFun 的高速开发经验往上推，主线不是“AI 多写了代码”，而是协作对象变了。过去我们主要管理人和人之间的协作，以及代码进入仓库的流程；现在多了异步 Agent、角色化 Agent、工具执行、测试结果、trace、风险说明和回滚路径。第一阶段是人和 AI 同步 pair coding，AI 在 IDE 或 chat 里帮你补全、解释和修改。第二阶段是异步委派，比如 GitHub Copilot cloud agent 或 Codex cloud：你把任务交给 Agent，它在独立环境里研究、建分支、跑测试、准备 PR。第三阶段是角色化 Agent：实现、测试、评审、安全、文档可能由不同 Agent 或不同流程承担。第四阶段仍然是人类放行，但人看的重点不是每一步 prompt，而是目标是否明确、证据是否足够、风险是否可接受、责任是否能落地。所以 AI 时代的软件工程，不是多一个助手，而是把任务、证据和责任一起纳入协作系统。
+转场：协作对象变多以后，真正的治理问题就出现了：AI 可以概率性探索，但系统必须确定性放行。</a:t>
             </a:r>
             <a:endParaRPr lang="en-US" dirty="0"/>
           </a:p>
@@ -1352,12 +1258,12 @@
           <a:p>
             <a:r>
               <a:rPr lang="en-US" dirty="0"/>
-              <a:t>第 5 页：速度的背后：概率执行，证据放行
-建议时长：约 1.5 分钟
-页内重点：加入概率性问题、高置信度、开发者信任与产品可信的关系。
-互动提问：同样的模型，为什么有的 Agent 可信，有的 Agent 不可信？
-讲稿：AI 介入之后，研发节奏会从排期驱动部分转向想法驱动：先快速探索，再用证据决定是否继续。但这里的核心不是“模型每次都确定正确”，恰恰相反，模型生成天然带有概率性。新的软件工程范式更像是：允许执行过程多路径探索，但最终放行必须依赖可复现证据。开发者信任来自 Agent 层的保护，比如只读计划、沙箱执行、危险操作拦截、失败回注上下文、trace 可回放；产品可信来自测试、评估集、灰度、监控和人工审批。换句话说，我们不是消灭概率性，而是把概率性关进可观察、可比较、可回滚的工程边界里。
-转场：更尖锐的问题是：如果模型本身、团队使用的模型和多 Agent 链路都在波动，工程系统怎么收敛？</a:t>
+              <a:t>第 5 页：关键机制：概率过程，证据放行
+建议时长：约 1.6 分钟
+页内重点：说明如何用 Harness 保护、证据包、阶段门禁和人工判断收敛概率性过程。
+互动提问：如果每一步都有 99% 正确率，十步之后系统还可信吗？
+讲稿：这页是前面协作变化之后的关键机制：我们不要求 AI 的每一步都确定正确，而是允许过程概率性探索，同时把结果放行建立在确定性证据上。AI 的不确定性不只来自某一次回答，团队里不同人可能使用不同模型，同一模型不同版本能力也会波动；如果一个 Agent Team 中每一步都把前一步结论当事实输入，错误会像串联系统一样累乘，0.99 的十次方大约只有 0.90。解决办法不是让人类盯住每一步 prompt，而是建立阶段门禁和证据包。左边是概率探索层，Harness 要提供沙箱、权限、危险操作拦截、失败回注和 trace；中间是证据包，把 diff、测试、日志、风险、回滚路径压缩成人能判断的交付对象；右边是阶段门禁，在计划到实现、实现到评审、评审到合并这些阶段转换处检查完整性、契约、测试、owner 和风险。人类参与的重点也从过程监督变成判断辅助：看摘要、差异、来源、不一致提示和风险解释。也就是说，用可控系统解决不可控过程，核心不是记录更多细节，而是把复杂过程收敛为可审查、可复现、可回滚的证据。
+转场：有了这层纠偏系统，再看外部数据，会更容易理解为什么速度收益不是天然指数级增长。</a:t>
             </a:r>
             <a:endParaRPr lang="en-US" dirty="0"/>
           </a:p>
@@ -1445,12 +1351,12 @@
           <a:p>
             <a:r>
               <a:rPr lang="en-US" dirty="0"/>
-              <a:t>第 6 页：用可控系统收敛不可控过程
+              <a:t>第 6 页：速度收益不是指数曲线
 建议时长：约 1.2 分钟
-页内重点：补充模型波动、概率串联衰减、Agent Team 错误放大，以及阶段性纠错系统。
-互动提问：如果每一步都有 99% 正确率，十步之后系统还可信吗？
-讲稿：这里可以把问题说得更硬一点：AI 的不确定性不只来自某一次回答。团队里不同人可能使用不同模型，同一个模型不同版本能力会变化，甚至在 temperature 很低时同一评审任务也可能出现不一致。再往上，如果一个 Agent Team 中每一步都把前一步的自然语言结论当事实输入，错误就会像串联系统一样累乘：0.99 的十次方大约只有 0.90；更糟的是，很多错误不是独立随机错误，而是会被后续步骤继承并放大。但治理对象要切清楚：模型、提示词、工具调用这些是后台 telemetry，用于复现、审计和失败排查，不应该变成人类日常评审的主要对象。人类应该判断的是交付对象：需求意图是否明确，代码变更是否完整，测试和运行证据是否足够，风险和回滚是否可接受。阶段门禁就是放在阶段转换处的自动控制点，比如从计划到实现、从实现到评审、从评审到合并。它检查的是交付对象和证据包，而不是每一步操作日志：接口契约、影响范围、构建测试、静态检查、风险标签、owner 和回滚路径。Artifact 也要收窄成可长期管理的关键工程产物，包括需求/任务、设计决策、代码 diff、测试证据、评审结论、发布与回滚记录。系统把复杂执行过程压缩成摘要、差异、来源、不一致提示和风险解释，帮助人做判断；只有在高风险、证据冲突或事故复盘时，才需要下钻到模型和执行轨迹。
-转场：有了这层纠偏系统，再看外部数据，会更容易理解为什么速度收益不是天然指数级增长。</a:t>
+页内重点：补外部信息：DORA、METR、Harness 作为市场和研究佐证。
+互动提问：为什么开发者感觉更快，团队整体却未必同等加速？
+讲稿：外部研究给了我们一个更冷静的视角。DORA 2025 把 AI 描述为组织系统的放大器：高质量组织会被放大，原本碎片化的流程也会被放大；同时它也提醒，采用 AI 不等于自动获得收益，组织需要同步演进文化、流程和系统。METR 在 2025 对成熟开源项目做随机对照实验，发现经验开发者使用当时的 AI 工具反而慢 19%；2026 年 METR 又提醒，AI 工具正在进化，任务选择和多 Agent 使用让测量本身也变难。Harness 2026 则把问题落到工程管理上：很多团队的生产力指标变好，但 code review、修 bug、工具切换等隐形工作也在上升。结论不是 AI 没用，而是不要只用代码量衡量收益。
+转场：所以第一个真正被重新定义的东西，是质量责任。</a:t>
             </a:r>
             <a:endParaRPr lang="en-US" dirty="0"/>
           </a:p>
@@ -1538,12 +1444,12 @@
           <a:p>
             <a:r>
               <a:rPr lang="en-US" dirty="0"/>
-              <a:t>第 7 页：速度收益不是指数曲线
-建议时长：约 1.2 分钟
-页内重点：补外部信息：DORA、METR、Harness 作为市场和研究佐证。
-互动提问：为什么开发者感觉更快，团队整体却未必同等加速？
-讲稿：外部研究给了我们一个更冷静的视角。DORA 2025 把 AI 描述为组织系统的放大器：高质量组织会被放大，原本碎片化的流程也会被放大；同时它也提醒，采用 AI 不等于自动获得收益，组织需要同步演进文化、流程和系统。METR 在 2025 对成熟开源项目做随机对照实验，发现经验开发者使用当时的 AI 工具反而慢 19%；2026 年 METR 又提醒，AI 工具正在进化，任务选择和多 Agent 使用让测量本身也变难。Harness 2026 则把问题落到工程管理上：很多团队的生产力指标变好，但 code review、修 bug、工具切换等隐形工作也在上升。结论不是 AI 没用，而是不要只用代码量衡量收益。
-转场：所以第一个真正被重新定义的东西，是质量责任。</a:t>
+              <a:t>第 7 页：速度放大之后，质量责任被重新定义
+建议时长：约 1.0 分钟
+页内重点：解释从能跑到可放行的距离，承接前一页证据放行机制。
+互动提问：AI 生成的代码能跑之后，距离可合并、可发布、可长期维护还差什么？
+讲稿：当速度被放大之后，质量责任会从“这个功能能不能跑”扩展到“谁确认它可以进入系统”。功能能跑，只说明 happy path 暂时成立；设计不沉淀，意味着需求变化没有变成可复用的决策记录；协作被压缩，意味着个人加 Agent 很快，但团队共识可能不足；修复凭自信，意味着 Agent 可以给出看似合理的 patch，却没有复现、日志和验证。这里的关键是把“高置信度”从模型自信改成工程证据：证据不是附属材料，而是进入合并、发布和复盘的主路径。
+转场：质量责任落地以后，工程治理需要从门禁转向更细的智能护栏。</a:t>
             </a:r>
             <a:endParaRPr lang="en-US" dirty="0"/>
           </a:p>
@@ -1631,12 +1537,12 @@
           <a:p>
             <a:r>
               <a:rPr lang="en-US" dirty="0"/>
-              <a:t>第 8 页：速度放大之后，质量责任被重新定义
-建议时长：约 1.0 分钟
-页内重点：优化第六页：放大中部内容，解释从能跑到可放行的距离。
-互动提问：AI 生成的代码能跑之后，距离可合并、可发布、可长期维护还差什么？
-讲稿：当速度被放大之后，质量责任会从“这个功能能不能跑”扩展到“谁确认它可以进入系统”。功能能跑，只说明 happy path 暂时成立；设计不沉淀，意味着需求变化没有变成可复用的决策记录；协作被压缩，意味着个人加 Agent 很快，但团队共识可能不足；修复凭自信，意味着 Agent 可以给出看似合理的 patch，却没有复现、日志和验证。这里的关键是把“高置信度”从模型自信改成工程证据：证据不是附属材料，而是进入合并、发布和复盘的主路径。
-转场：质量责任落地以后，工程治理需要从门禁转向更细的智能护栏。</a:t>
+              <a:t>第 8 页：工程质量：从门禁到智能护栏
+建议时长：约 1.4 分钟
+页内重点：突出开源与大厂场景中的责任链、证据链与小批量反制不稳定。
+互动提问：AI 让提交变多以后，维护者和大厂平台到底该看什么？
+讲稿：原先第七页和第八页容易讲成重复的质量术语，这里把它收敛为一个治理问题：开源高质量协作强调公共责任，维护者要提升对陌生贡献或 AI-assisted 变更质量的信任度；大厂复杂交付强调系统连续性，组织要处理 owner、依赖链、合规、发布窗口、线上事故成本，以及贯穿整个系统的确定性工件。两者都不能只靠“多跑测试”。更有效的做法是把变化拆小，把责任、证据和 Artifact 绑定到每个小批次：谁拥有模块，谁确认设计边界，哪些测试和运行指标证明可以前进，失败时如何回滚。
+转场：再往前看，DFX、TDD、架构守护都会出现 AI 时代的新形态。</a:t>
             </a:r>
             <a:endParaRPr lang="en-US" dirty="0"/>
           </a:p>
@@ -1724,12 +1630,12 @@
           <a:p>
             <a:r>
               <a:rPr lang="en-US" dirty="0"/>
-              <a:t>第 9 页：工程质量：从门禁到智能护栏
-建议时长：约 1.4 分钟
-页内重点：合并原第七/第八页的重复信息，突出责任链、证据链与小批量反制不稳定。
-互动提问：AI 让提交变多以后，维护者和大厂平台到底该看什么？
-讲稿：原先第七页和第八页容易讲成重复的质量术语，这里把它收敛为一个治理问题：开源高质量协作强调公共责任，维护者要提升对陌生贡献或 AI-assisted 变更质量的信任度；大厂复杂交付强调系统连续性，组织要处理 owner、依赖链、合规、发布窗口、线上事故成本，以及贯穿整个系统的确定性工件。两者都不能只靠“多跑测试”。更有效的做法是把变化拆小，把责任、证据和 Artifact 绑定到每个小批次：谁拥有模块，谁确认设计边界，哪些测试和运行指标证明可以前进，失败时如何回滚。
-转场：再往前看，DFX、TDD、架构守护都会出现 AI 时代的新形态。</a:t>
+              <a:t>第 9 页：下一代工程方法：让 DFX 与 TDD 变成 Agent 协议
+建议时长：约 1.3 分钟
+页内重点：回应 DFX/TDD 新形态：非特定工程的 AI 下解决方案、细化军规、用例形态升级。
+互动提问：如果代码军规仍会被幻觉绕过，下一层护栏是什么？
+讲稿：这里可以做一个前瞻判断：AI 时代的 DFX 不会只是 Design for X 的静态清单，而会变成一组可执行的 Agent 协议。比如性能、可观测性、安全、可维护性，不再只写在规范里，而是以检查项、基准、trace、回归用例、发布预算的形式进入 Agent 工作流。TDD 也会扩展：不只是先写单元测试再写实现，而是先定义失败证据、属性约束、运行观测和评估集，再让 Agent 在这些证据边界里修改。代码军规仍会有幻觉，所以规则要更细，但更关键的是规则要可执行：能被工具检查、能被 trace 回放、能被 review 独立仲裁。
+转场：把这些方法落到 BitFun，就能看到一个 Agent 工程系统的雏形。</a:t>
             </a:r>
             <a:endParaRPr lang="en-US" dirty="0"/>
           </a:p>
@@ -2358,62 +2264,6 @@
 </p:sld>
 </file>
 
-<file path=ppt/slides/slide14.xml><?xml version="1.0" encoding="utf-8"?>
-<p:sld xmlns:a="http://schemas.openxmlformats.org/drawingml/2006/main" xmlns:r="http://schemas.openxmlformats.org/officeDocument/2006/relationships" xmlns:p="http://schemas.openxmlformats.org/presentationml/2006/main">
-  <p:cSld name="Slide 14">
-    <p:bg>
-      <p:bgPr>
-        <a:solidFill>
-          <a:srgbClr val="F6F8FB"/>
-        </a:solidFill>
-      </p:bgPr>
-    </p:bg>
-    <p:spTree>
-      <p:nvGrpSpPr>
-        <p:cNvPr id="1" name=""/>
-        <p:cNvGrpSpPr/>
-        <p:nvPr/>
-      </p:nvGrpSpPr>
-      <p:grpSpPr>
-        <a:xfrm>
-          <a:off x="0" y="0"/>
-          <a:ext cx="0" cy="0"/>
-          <a:chOff x="0" y="0"/>
-          <a:chExt cx="0" cy="0"/>
-        </a:xfrm>
-      </p:grpSpPr>
-      <p:pic>
-        <p:nvPicPr>
-          <p:cNvPr id="2" name="Image 0" descr="D:\workspace\worktree_for_vcoder\BitFun\docs\report\ai-redefines-software-development-presentation\slides-png-v0.2\slide-14.png">    </p:cNvPr>
-          <p:cNvPicPr>
-            <a:picLocks noChangeAspect="1"/>
-          </p:cNvPicPr>
-          <p:nvPr/>
-        </p:nvPicPr>
-        <p:blipFill>
-          <a:blip r:embed="rId1"/>
-          <a:stretch>
-            <a:fillRect/>
-          </a:stretch>
-        </p:blipFill>
-        <p:spPr>
-          <a:xfrm>
-            <a:off x="0" y="0"/>
-            <a:ext cx="12191695" cy="6858000"/>
-          </a:xfrm>
-          <a:prstGeom prst="rect">
-            <a:avLst/>
-          </a:prstGeom>
-        </p:spPr>
-      </p:pic>
-    </p:spTree>
-  </p:cSld>
-  <p:clrMapOvr>
-    <a:masterClrMapping/>
-  </p:clrMapOvr>
-</p:sld>
-</file>
-
 <file path=ppt/slides/slide2.xml><?xml version="1.0" encoding="utf-8"?>
 <p:sld xmlns:a="http://schemas.openxmlformats.org/drawingml/2006/main" xmlns:r="http://schemas.openxmlformats.org/officeDocument/2006/relationships" xmlns:p="http://schemas.openxmlformats.org/presentationml/2006/main">
   <p:cSld name="Slide 2">

</xml_diff>